<commit_message>
docs(av1): relatório e slides com os resultados reais; decisões D-22 a D-24
Leitura dos resultados em 4.4 a 4.8, capturas de tela (fundo da tela de
bloqueio removido), causa do corte do GPS com a tela apagada (faltava a
localização em segundo plano, D-23) e declaração de uso de IA com o Codex
do Juliano. Slides com os números reais, sem roteiro nas notas.

Código gerado com assistente de IA (Claude); declaração na seção 8 do relatório.

Co-authored-by: Andre Bueno Ocanha <andre.ocanha@estudante.ufla.br>
Co-Authored-By: Claude Opus 5.5 <noreply@anthropic.com>
Claude-Session: https://claude.ai/code/session_01W6tNBw7crDxiBqVKr8oJJ5
</commit_message>
<xml_diff>
--- a/docs/presentations/apresentacao_I_AV1.pptx
+++ b/docs/presentations/apresentacao_I_AV1.pptx
@@ -3517,14 +3517,14 @@
                 <a:gridCol w="3780000"/>
                 <a:gridCol w="3780000"/>
               </a:tblGrid>
-              <a:tr h="540000">
+              <a:tr h="480000">
                 <a:tc>
                   <a:txBody>
                     <a:bodyPr/>
                     <a:lstStyle/>
                     <a:p>
                       <a:r>
-                        <a:rPr sz="1700" b="1">
+                        <a:rPr sz="1500" b="1">
                           <a:solidFill>
                             <a:srgbClr val="FFFFFF"/>
                           </a:solidFill>
@@ -3546,7 +3546,7 @@
                     <a:lstStyle/>
                     <a:p>
                       <a:r>
-                        <a:rPr sz="1700" b="1">
+                        <a:rPr sz="1500" b="1">
                           <a:solidFill>
                             <a:srgbClr val="FFFFFF"/>
                           </a:solidFill>
@@ -3568,7 +3568,7 @@
                     <a:lstStyle/>
                     <a:p>
                       <a:r>
-                        <a:rPr sz="1700" b="1">
+                        <a:rPr sz="1500" b="1">
                           <a:solidFill>
                             <a:srgbClr val="FFFFFF"/>
                           </a:solidFill>
@@ -3585,14 +3585,14 @@
                   </a:tcPr>
                 </a:tc>
               </a:tr>
-              <a:tr h="540000">
+              <a:tr h="480000">
                 <a:tc>
                   <a:txBody>
                     <a:bodyPr/>
                     <a:lstStyle/>
                     <a:p>
                       <a:r>
-                        <a:rPr sz="1700" b="0">
+                        <a:rPr sz="1500" b="0">
                           <a:solidFill>
                             <a:srgbClr val="0D0F14"/>
                           </a:solidFill>
@@ -3614,7 +3614,7 @@
                     <a:lstStyle/>
                     <a:p>
                       <a:r>
-                        <a:rPr sz="1700" b="0">
+                        <a:rPr sz="1500" b="0">
                           <a:solidFill>
                             <a:srgbClr val="0D0F14"/>
                           </a:solidFill>
@@ -3636,13 +3636,13 @@
                     <a:lstStyle/>
                     <a:p>
                       <a:r>
-                        <a:rPr sz="1700" b="0">
+                        <a:rPr sz="1500" b="0">
                           <a:solidFill>
                             <a:srgbClr val="0D0F14"/>
                           </a:solidFill>
                           <a:latin typeface="Plus Jakarta Sans"/>
                         </a:rPr>
-                        <a:t>⟪após a coleta⟫</a:t>
+                        <a:t>ver testes_unidade.md</a:t>
                       </a:r>
                     </a:p>
                   </a:txBody>
@@ -3653,14 +3653,14 @@
                   </a:tcPr>
                 </a:tc>
               </a:tr>
-              <a:tr h="540000">
+              <a:tr h="480000">
                 <a:tc>
                   <a:txBody>
                     <a:bodyPr/>
                     <a:lstStyle/>
                     <a:p>
                       <a:r>
-                        <a:rPr sz="1700" b="0">
+                        <a:rPr sz="1500" b="0">
                           <a:solidFill>
                             <a:srgbClr val="0D0F14"/>
                           </a:solidFill>
@@ -3682,7 +3682,7 @@
                     <a:lstStyle/>
                     <a:p>
                       <a:r>
-                        <a:rPr sz="1700" b="0">
+                        <a:rPr sz="1500" b="0">
                           <a:solidFill>
                             <a:srgbClr val="0D0F14"/>
                           </a:solidFill>
@@ -3704,13 +3704,13 @@
                     <a:lstStyle/>
                     <a:p>
                       <a:r>
-                        <a:rPr sz="1700" b="0">
+                        <a:rPr sz="1500" b="0">
                           <a:solidFill>
                             <a:srgbClr val="0D0F14"/>
                           </a:solidFill>
                           <a:latin typeface="Plus Jakarta Sans"/>
                         </a:rPr>
-                        <a:t>⟪após a coleta⟫</a:t>
+                        <a:t>ver corrida_10_execucoes.md</a:t>
                       </a:r>
                     </a:p>
                   </a:txBody>
@@ -3721,14 +3721,14 @@
                   </a:tcPr>
                 </a:tc>
               </a:tr>
-              <a:tr h="540000">
+              <a:tr h="480000">
                 <a:tc>
                   <a:txBody>
                     <a:bodyPr/>
                     <a:lstStyle/>
                     <a:p>
                       <a:r>
-                        <a:rPr sz="1700" b="0">
+                        <a:rPr sz="1500" b="0">
                           <a:solidFill>
                             <a:srgbClr val="0D0F14"/>
                           </a:solidFill>
@@ -3750,7 +3750,7 @@
                     <a:lstStyle/>
                     <a:p>
                       <a:r>
-                        <a:rPr sz="1700" b="0">
+                        <a:rPr sz="1500" b="0">
                           <a:solidFill>
                             <a:srgbClr val="0D0F14"/>
                           </a:solidFill>
@@ -3772,13 +3772,13 @@
                     <a:lstStyle/>
                     <a:p>
                       <a:r>
-                        <a:rPr sz="1700" b="0">
+                        <a:rPr sz="1500" b="0">
                           <a:solidFill>
                             <a:srgbClr val="0D0F14"/>
                           </a:solidFill>
                           <a:latin typeface="Plus Jakarta Sans"/>
                         </a:rPr>
-                        <a:t>⟪após a coleta⟫</a:t>
+                        <a:t>36,2 min · IMU 50,0 Hz · 0 leituras perdidas</a:t>
                       </a:r>
                     </a:p>
                   </a:txBody>
@@ -3789,20 +3789,20 @@
                   </a:tcPr>
                 </a:tc>
               </a:tr>
-              <a:tr h="540000">
+              <a:tr h="480000">
                 <a:tc>
                   <a:txBody>
                     <a:bodyPr/>
                     <a:lstStyle/>
                     <a:p>
                       <a:r>
-                        <a:rPr sz="1700" b="0">
+                        <a:rPr sz="1500" b="0">
                           <a:solidFill>
                             <a:srgbClr val="0D0F14"/>
                           </a:solidFill>
                           <a:latin typeface="Plus Jakarta Sans"/>
                         </a:rPr>
-                        <a:t>Consumo</a:t>
+                        <a:t>Posição com a tela apagada</a:t>
                       </a:r>
                     </a:p>
                   </a:txBody>
@@ -3818,13 +3818,13 @@
                     <a:lstStyle/>
                     <a:p>
                       <a:r>
-                        <a:rPr sz="1700" b="0">
+                        <a:rPr sz="1500" b="0">
                           <a:solidFill>
                             <a:srgbClr val="0D0F14"/>
                           </a:solidFill>
                           <a:latin typeface="Plus Jakarta Sans"/>
                         </a:rPr>
-                        <a:t>bateria durante o trecho</a:t>
+                        <a:t>mesmo trecho</a:t>
                       </a:r>
                     </a:p>
                   </a:txBody>
@@ -3840,13 +3840,13 @@
                     <a:lstStyle/>
                     <a:p>
                       <a:r>
-                        <a:rPr sz="1700" b="0">
+                        <a:rPr sz="1500" b="0">
                           <a:solidFill>
                             <a:srgbClr val="0D0F14"/>
                           </a:solidFill>
                           <a:latin typeface="Plus Jakarta Sans"/>
                         </a:rPr>
-                        <a:t>⟪após a coleta⟫</a:t>
+                        <a:t>GPS em 62% do tempo · sem GPS, rede a cada ≤ 20 s (r68 100 m)</a:t>
                       </a:r>
                     </a:p>
                   </a:txBody>
@@ -3857,20 +3857,20 @@
                   </a:tcPr>
                 </a:tc>
               </a:tr>
-              <a:tr h="540000">
+              <a:tr h="480000">
                 <a:tc>
                   <a:txBody>
                     <a:bodyPr/>
                     <a:lstStyle/>
                     <a:p>
                       <a:r>
-                        <a:rPr sz="1700" b="0">
+                        <a:rPr sz="1500" b="0">
                           <a:solidFill>
                             <a:srgbClr val="0D0F14"/>
                           </a:solidFill>
                           <a:latin typeface="Plus Jakarta Sans"/>
                         </a:rPr>
-                        <a:t>Razão de otimismo</a:t>
+                        <a:t>Consumo</a:t>
                       </a:r>
                     </a:p>
                   </a:txBody>
@@ -3886,13 +3886,13 @@
                     <a:lstStyle/>
                     <a:p>
                       <a:r>
-                        <a:rPr sz="1700" b="0">
+                        <a:rPr sz="1500" b="0">
                           <a:solidFill>
                             <a:srgbClr val="0D0F14"/>
                           </a:solidFill>
                           <a:latin typeface="Plus Jakarta Sans"/>
                         </a:rPr>
-                        <a:t>aparelho parado, céu aberto</a:t>
+                        <a:t>bateria durante o trecho</a:t>
                       </a:r>
                     </a:p>
                   </a:txBody>
@@ -3908,13 +3908,13 @@
                     <a:lstStyle/>
                     <a:p>
                       <a:r>
-                        <a:rPr sz="1700" b="0">
+                        <a:rPr sz="1500" b="0">
                           <a:solidFill>
                             <a:srgbClr val="0D0F14"/>
                           </a:solidFill>
                           <a:latin typeface="Plus Jakarta Sans"/>
                         </a:rPr>
-                        <a:t>⟪após a coleta⟫</a:t>
+                        <a:t>8,3 %/h</a:t>
                       </a:r>
                     </a:p>
                   </a:txBody>
@@ -3925,20 +3925,20 @@
                   </a:tcPr>
                 </a:tc>
               </a:tr>
-              <a:tr h="540000">
+              <a:tr h="480000">
                 <a:tc>
                   <a:txBody>
                     <a:bodyPr/>
                     <a:lstStyle/>
                     <a:p>
                       <a:r>
-                        <a:rPr sz="1700" b="0">
+                        <a:rPr sz="1500" b="0">
                           <a:solidFill>
                             <a:srgbClr val="0D0F14"/>
                           </a:solidFill>
                           <a:latin typeface="Plus Jakarta Sans"/>
                         </a:rPr>
-                        <a:t>Resíduo RMS</a:t>
+                        <a:t>Razão de otimismo</a:t>
                       </a:r>
                     </a:p>
                   </a:txBody>
@@ -3954,13 +3954,13 @@
                     <a:lstStyle/>
                     <a:p>
                       <a:r>
-                        <a:rPr sz="1700" b="0">
+                        <a:rPr sz="1500" b="0">
                           <a:solidFill>
                             <a:srgbClr val="0D0F14"/>
                           </a:solidFill>
                           <a:latin typeface="Plus Jakarta Sans"/>
                         </a:rPr>
-                        <a:t>≥ 3 janelas reais</a:t>
+                        <a:t>aparelho parado, mesma sessão</a:t>
                       </a:r>
                     </a:p>
                   </a:txBody>
@@ -3976,13 +3976,13 @@
                     <a:lstStyle/>
                     <a:p>
                       <a:r>
-                        <a:rPr sz="1700" b="0">
+                        <a:rPr sz="1500" b="0">
                           <a:solidFill>
                             <a:srgbClr val="0D0F14"/>
                           </a:solidFill>
                           <a:latin typeface="Plus Jakarta Sans"/>
                         </a:rPr>
-                        <a:t>⟪após a coleta⟫</a:t>
+                        <a:t>3,32</a:t>
                       </a:r>
                     </a:p>
                   </a:txBody>
@@ -3993,20 +3993,20 @@
                   </a:tcPr>
                 </a:tc>
               </a:tr>
-              <a:tr h="540000">
+              <a:tr h="480000">
                 <a:tc>
                   <a:txBody>
                     <a:bodyPr/>
                     <a:lstStyle/>
                     <a:p>
                       <a:r>
-                        <a:rPr sz="1700" b="0">
+                        <a:rPr sz="1500" b="0">
                           <a:solidFill>
                             <a:srgbClr val="0D0F14"/>
                           </a:solidFill>
                           <a:latin typeface="Plus Jakarta Sans"/>
                         </a:rPr>
-                        <a:t>Salto mínimo detectável</a:t>
+                        <a:t>Resíduo RMS</a:t>
                       </a:r>
                     </a:p>
                   </a:txBody>
@@ -4022,13 +4022,13 @@
                     <a:lstStyle/>
                     <a:p>
                       <a:r>
-                        <a:rPr sz="1700" b="0">
+                        <a:rPr sz="1500" b="0">
                           <a:solidFill>
                             <a:srgbClr val="0D0F14"/>
                           </a:solidFill>
                           <a:latin typeface="Plus Jakarta Sans"/>
                         </a:rPr>
-                        <a:t>≥ 90% de detecção</a:t>
+                        <a:t>85 janelas reais da caminhada</a:t>
                       </a:r>
                     </a:p>
                   </a:txBody>
@@ -4044,13 +4044,13 @@
                     <a:lstStyle/>
                     <a:p>
                       <a:r>
-                        <a:rPr sz="1700" b="0">
+                        <a:rPr sz="1500" b="0">
                           <a:solidFill>
                             <a:srgbClr val="0D0F14"/>
                           </a:solidFill>
                           <a:latin typeface="Plus Jakarta Sans"/>
                         </a:rPr>
-                        <a:t>⟪após a coleta⟫</a:t>
+                        <a:t>0,24 m → 2e-15 m</a:t>
                       </a:r>
                     </a:p>
                   </a:txBody>
@@ -4061,6 +4061,74 @@
                   </a:tcPr>
                 </a:tc>
               </a:tr>
+              <a:tr h="480000">
+                <a:tc>
+                  <a:txBody>
+                    <a:bodyPr/>
+                    <a:lstStyle/>
+                    <a:p>
+                      <a:r>
+                        <a:rPr sz="1500" b="0">
+                          <a:solidFill>
+                            <a:srgbClr val="0D0F14"/>
+                          </a:solidFill>
+                          <a:latin typeface="Plus Jakarta Sans"/>
+                        </a:rPr>
+                        <a:t>Salto mínimo detectável</a:t>
+                      </a:r>
+                    </a:p>
+                  </a:txBody>
+                  <a:tcPr>
+                    <a:solidFill>
+                      <a:srgbClr val="F4F5F9"/>
+                    </a:solidFill>
+                  </a:tcPr>
+                </a:tc>
+                <a:tc>
+                  <a:txBody>
+                    <a:bodyPr/>
+                    <a:lstStyle/>
+                    <a:p>
+                      <a:r>
+                        <a:rPr sz="1500" b="0">
+                          <a:solidFill>
+                            <a:srgbClr val="0D0F14"/>
+                          </a:solidFill>
+                          <a:latin typeface="Plus Jakarta Sans"/>
+                        </a:rPr>
+                        <a:t>≥ 90% de detecção</a:t>
+                      </a:r>
+                    </a:p>
+                  </a:txBody>
+                  <a:tcPr>
+                    <a:solidFill>
+                      <a:srgbClr val="F4F5F9"/>
+                    </a:solidFill>
+                  </a:tcPr>
+                </a:tc>
+                <a:tc>
+                  <a:txBody>
+                    <a:bodyPr/>
+                    <a:lstStyle/>
+                    <a:p>
+                      <a:r>
+                        <a:rPr sz="1500" b="0">
+                          <a:solidFill>
+                            <a:srgbClr val="0D0F14"/>
+                          </a:solidFill>
+                          <a:latin typeface="Plus Jakarta Sans"/>
+                        </a:rPr>
+                        <a:t>5 m</a:t>
+                      </a:r>
+                    </a:p>
+                  </a:txBody>
+                  <a:tcPr>
+                    <a:solidFill>
+                      <a:srgbClr val="F4F5F9"/>
+                    </a:solidFill>
+                  </a:tcPr>
+                </a:tc>
+              </a:tr>
             </a:tbl>
           </a:graphicData>
         </a:graphic>
@@ -4099,7 +4167,7 @@
                 </a:solidFill>
                 <a:latin typeface="Plus Jakarta Sans"/>
               </a:rPr>
-              <a:t>Aparelho: ⟪modelo, Android⟫ · local: ⟪campus⟫ · data: ⟪data⟫ · comando: scripts\av1_evidencias.ps1 · semente 20261020</a:t>
+              <a:t>Aparelho: Samsung SM-S926B · local: campus da UFLA · coletas: 22/10/2026 · comando: scripts\av1_evidencias.ps1 · semente 20261020</a:t>
             </a:r>
           </a:p>
         </p:txBody>
@@ -4311,7 +4379,7 @@
               </a:spcAft>
             </a:pPr>
             <a:r>
-              <a:rPr sz="1900" b="1">
+              <a:rPr sz="1700" b="1">
                 <a:solidFill>
                   <a:srgbClr val="0D0F14"/>
                 </a:solidFill>
@@ -4327,7 +4395,7 @@
               </a:spcAft>
             </a:pPr>
             <a:r>
-              <a:rPr sz="1900" b="0">
+              <a:rPr sz="1700" b="0">
                 <a:solidFill>
                   <a:srgbClr val="0D0F14"/>
                 </a:solidFill>
@@ -4343,7 +4411,7 @@
               </a:spcAft>
             </a:pPr>
             <a:r>
-              <a:rPr sz="1900" b="0">
+              <a:rPr sz="1700" b="0">
                 <a:solidFill>
                   <a:srgbClr val="0D0F14"/>
                 </a:solidFill>
@@ -4359,23 +4427,39 @@
               </a:spcAft>
             </a:pPr>
             <a:r>
-              <a:rPr sz="1900" b="0">
-                <a:solidFill>
-                  <a:srgbClr val="0D0F14"/>
-                </a:solidFill>
-                <a:latin typeface="Plus Jakarta Sans"/>
-              </a:rPr>
-              <a:t>IMU sem reconciliação: a API não informa σ por eixo.</a:t>
-            </a:r>
-          </a:p>
-          <a:p>
-            <a:pPr algn="l">
-              <a:spcAft>
-                <a:spcPts val="400"/>
-              </a:spcAft>
-            </a:pPr>
-            <a:r>
-              <a:rPr sz="1900" b="0">
+              <a:rPr sz="1700" b="0">
+                <a:solidFill>
+                  <a:srgbClr val="0D0F14"/>
+                </a:solidFill>
+                <a:latin typeface="Plus Jakarta Sans"/>
+              </a:rPr>
+              <a:t>Sessão gravada: GPS parou ~3 min após a tela apagar (faltava a localização em segundo plano; corrigido e conferido em teste curto).</a:t>
+            </a:r>
+          </a:p>
+          <a:p>
+            <a:pPr algn="l">
+              <a:spcAft>
+                <a:spcPts val="400"/>
+              </a:spcAft>
+            </a:pPr>
+            <a:r>
+              <a:rPr sz="1700" b="0">
+                <a:solidFill>
+                  <a:srgbClr val="0D0F14"/>
+                </a:solidFill>
+                <a:latin typeface="Plus Jakarta Sans"/>
+              </a:rPr>
+              <a:t>Parado, o receptor retém a posição: a razão de otimismo mistura viés inicial e posição congelada.</a:t>
+            </a:r>
+          </a:p>
+          <a:p>
+            <a:pPr algn="l">
+              <a:spcAft>
+                <a:spcPts val="400"/>
+              </a:spcAft>
+            </a:pPr>
+            <a:r>
+              <a:rPr sz="1700" b="0">
                 <a:solidFill>
                   <a:srgbClr val="0D0F14"/>
                 </a:solidFill>
@@ -4441,6 +4525,22 @@
                 <a:latin typeface="Plus Jakarta Sans"/>
               </a:rPr>
               <a:t>AV2</a:t>
+            </a:r>
+          </a:p>
+          <a:p>
+            <a:pPr algn="l">
+              <a:spcAft>
+                <a:spcPts val="400"/>
+              </a:spcAft>
+            </a:pPr>
+            <a:r>
+              <a:rPr sz="1900" b="0">
+                <a:solidFill>
+                  <a:srgbClr val="0D0F14"/>
+                </a:solidFill>
+                <a:latin typeface="Plus Jakarta Sans"/>
+              </a:rPr>
+              <a:t>Pedir a localização em segundo plano dentro do app e regravar os 30 min com GPS</a:t>
             </a:r>
           </a:p>
           <a:p>
@@ -5723,129 +5823,30 @@
           </a:p>
         </p:txBody>
       </p:sp>
-      <p:sp>
-        <p:nvSpPr>
-          <p:cNvPr id="7" name="Rounded Rectangle 6"/>
-          <p:cNvSpPr/>
+      <p:pic>
+        <p:nvPicPr>
+          <p:cNvPr id="7" name="Picture 6" descr="dispersao_estatica.png"/>
+          <p:cNvPicPr>
+            <a:picLocks noChangeAspect="1"/>
+          </p:cNvPicPr>
           <p:nvPr/>
-        </p:nvSpPr>
-        <p:spPr>
-          <a:xfrm>
-            <a:off x="6660000" y="1080000"/>
-            <a:ext cx="5040000" cy="3240000"/>
-          </a:xfrm>
-          <a:prstGeom prst="roundRect">
-            <a:avLst>
-              <a:gd name="adj" fmla="val 6000"/>
-            </a:avLst>
+        </p:nvPicPr>
+        <p:blipFill>
+          <a:blip r:embed="rId2"/>
+          <a:stretch>
+            <a:fillRect/>
+          </a:stretch>
+        </p:blipFill>
+        <p:spPr>
+          <a:xfrm>
+            <a:off x="6660000" y="1007999"/>
+            <a:ext cx="4536539" cy="4860000"/>
+          </a:xfrm>
+          <a:prstGeom prst="rect">
+            <a:avLst/>
           </a:prstGeom>
-          <a:solidFill>
-            <a:srgbClr val="F4F5F9"/>
-          </a:solidFill>
-          <a:ln>
-            <a:noFill/>
-          </a:ln>
-          <a:effectLst/>
-        </p:spPr>
-        <p:style>
-          <a:lnRef idx="1">
-            <a:schemeClr val="accent1"/>
-          </a:lnRef>
-          <a:fillRef idx="3">
-            <a:schemeClr val="accent1"/>
-          </a:fillRef>
-          <a:effectRef idx="2">
-            <a:schemeClr val="accent1"/>
-          </a:effectRef>
-          <a:fontRef idx="minor">
-            <a:schemeClr val="lt1"/>
-          </a:fontRef>
-        </p:style>
-        <p:txBody>
-          <a:bodyPr rtlCol="0" anchor="t" wrap="square" lIns="90000" rIns="90000" tIns="54000" bIns="54000"/>
-          <a:lstStyle/>
-          <a:p>
-            <a:pPr algn="l">
-              <a:spcAft>
-                <a:spcPts val="400"/>
-              </a:spcAft>
-            </a:pPr>
-            <a:r>
-              <a:rPr sz="1500" b="1">
-                <a:solidFill>
-                  <a:srgbClr val="0D0F14"/>
-                </a:solidFill>
-                <a:latin typeface="Plus Jakarta Sans"/>
-              </a:rPr>
-              <a:t>Ensaio estático (4.5)</a:t>
-            </a:r>
-          </a:p>
-          <a:p>
-            <a:pPr algn="l">
-              <a:spcAft>
-                <a:spcPts val="400"/>
-              </a:spcAft>
-            </a:pPr>
-            <a:r>
-              <a:rPr sz="1500" b="0">
-                <a:solidFill>
-                  <a:srgbClr val="0D0F14"/>
-                </a:solidFill>
-                <a:latin typeface="Plus Jakarta Sans"/>
-              </a:rPr>
-              <a:t>razão de otimismo = σ medido / σ declarado = ⟪após a coleta⟫</a:t>
-            </a:r>
-          </a:p>
-          <a:p>
-            <a:pPr algn="l">
-              <a:spcAft>
-                <a:spcPts val="400"/>
-              </a:spcAft>
-            </a:pPr>
-            <a:r>
-              <a:rPr sz="1500" b="0">
-                <a:solidFill>
-                  <a:srgbClr val="0D0F14"/>
-                </a:solidFill>
-                <a:latin typeface="Plus Jakarta Sans"/>
-              </a:rPr>
-              <a:t>fixos dentro do próprio r68: ⟪após a coleta⟫ (esperado 68%)</a:t>
-            </a:r>
-          </a:p>
-          <a:p>
-            <a:pPr algn="l">
-              <a:spcAft>
-                <a:spcPts val="400"/>
-              </a:spcAft>
-            </a:pPr>
-            <a:r>
-              <a:rPr sz="1500" b="0">
-                <a:solidFill>
-                  <a:srgbClr val="0D0F14"/>
-                </a:solidFill>
-                <a:latin typeface="Plus Jakarta Sans"/>
-              </a:rPr>
-              <a:t/>
-            </a:r>
-          </a:p>
-          <a:p>
-            <a:pPr algn="l">
-              <a:spcAft>
-                <a:spcPts val="400"/>
-              </a:spcAft>
-            </a:pPr>
-            <a:r>
-              <a:rPr sz="1500" b="0">
-                <a:solidFill>
-                  <a:srgbClr val="0D0F14"/>
-                </a:solidFill>
-                <a:latin typeface="Plus Jakarta Sans"/>
-              </a:rPr>
-              <a:t>&gt; 1: o sensor promete mais do que entrega → Σ pequena demais → falsos alarmes.</a:t>
-            </a:r>
-          </a:p>
-        </p:txBody>
-      </p:sp>
+        </p:spPr>
+      </p:pic>
     </p:spTree>
   </p:cSld>
   <p:clrMapOvr>
@@ -6646,7 +6647,7 @@
                 </a:solidFill>
                 <a:latin typeface="Plus Jakarta Sans"/>
               </a:rPr>
-              <a:t>vizinhos SEM detector: ⟪após a coleta⟫</a:t>
+              <a:t>vizinhos SEM detector: 2,94 m</a:t>
             </a:r>
           </a:p>
           <a:p>
@@ -6662,7 +6663,7 @@
                 </a:solidFill>
                 <a:latin typeface="Plus Jakarta Sans"/>
               </a:rPr>
-              <a:t>vizinhos COM detector: ⟪após a coleta⟫</a:t>
+              <a:t>vizinhos COM detector: 0,07 m</a:t>
             </a:r>
           </a:p>
           <a:p>
@@ -7592,7 +7593,7 @@
                 </a:solidFill>
                 <a:latin typeface="Plus Jakarta Sans"/>
               </a:rPr>
-              <a:t>menor salto com ≥ 90% de detecção = ⟪após a coleta⟫</a:t>
+              <a:t>menor salto com ≥ 90% de detecção = 5 m</a:t>
             </a:r>
           </a:p>
           <a:p>
@@ -7608,7 +7609,7 @@
                 </a:solidFill>
                 <a:latin typeface="Plus Jakarta Sans"/>
               </a:rPr>
-              <a:t>Falso alarme sem salto: ⟪após a coleta⟫</a:t>
+              <a:t>Falso alarme sem salto: 0%</a:t>
             </a:r>
           </a:p>
         </p:txBody>
@@ -7894,7 +7895,7 @@
                 </a:solidFill>
                 <a:latin typeface="Plus Jakarta Sans"/>
               </a:rPr>
-              <a:t>notificação na tela de bloqueio: Fixos GNSS · IMU · tempo subindo (ativado 30+ min antes)</a:t>
+              <a:t>notificação na tela de bloqueio: fixos GNSS, IMU e tempo subindo (ativado 30+ min antes; "Permitir o tempo todo", economia de energia desligada)</a:t>
             </a:r>
           </a:p>
         </p:txBody>

</xml_diff>

<commit_message>
docs(av1): relatório e slides com a sessão nova; decisões D-22, D-23 e D-25
Seção 4.4 com as duas sessões bloqueadas e a comparação antes e depois da
D-23; 4.5 explica por que o ensaio estático mede a retenção de posição e
não o ruído. D-22: a espera de 100 ms não eliminou as linhas sem lote IMU;
a correção de verdade (consumidor com taxa fixa) fica para a AV2. D-25:
coordenadas deslocadas na sessão gravada fora do campus. Tabelas longas no
Apêndice B, para o corpo caber em 15 páginas.

Código gerado com assistente de IA (Claude); declaração na seção 8 do relatório.

Co-authored-by: Andre Bueno Ocanha <andre.ocanha@estudante.ufla.br>
Co-Authored-By: Claude Opus 5.5 <noreply@anthropic.com>
Claude-Session: https://claude.ai/code/session_01W6tNBw7crDxiBqVKr8oJJ5
</commit_message>
<xml_diff>
--- a/docs/presentations/apresentacao_I_AV1.pptx
+++ b/docs/presentations/apresentacao_I_AV1.pptx
@@ -3778,7 +3778,7 @@
                           </a:solidFill>
                           <a:latin typeface="Plus Jakarta Sans"/>
                         </a:rPr>
-                        <a:t>36,2 min · IMU 50,0 Hz · 0 leituras perdidas</a:t>
+                        <a:t>36,3 min · IMU 50,1 Hz · 0 leituras perdidas</a:t>
                       </a:r>
                     </a:p>
                   </a:txBody>
@@ -3802,7 +3802,7 @@
                           </a:solidFill>
                           <a:latin typeface="Plus Jakarta Sans"/>
                         </a:rPr>
-                        <a:t>Posição com a tela apagada</a:t>
+                        <a:t>GPS com a tela apagada</a:t>
                       </a:r>
                     </a:p>
                   </a:txBody>
@@ -3824,7 +3824,7 @@
                           </a:solidFill>
                           <a:latin typeface="Plus Jakarta Sans"/>
                         </a:rPr>
-                        <a:t>mesmo trecho</a:t>
+                        <a:t>mesmo trecho; antes da D-23 entre parênteses</a:t>
                       </a:r>
                     </a:p>
                   </a:txBody>
@@ -3846,7 +3846,7 @@
                           </a:solidFill>
                           <a:latin typeface="Plus Jakarta Sans"/>
                         </a:rPr>
-                        <a:t>GPS em 62% do tempo · sem GPS, rede a cada ≤ 20 s (r68 100 m)</a:t>
+                        <a:t>87% do tempo (62%) · sem GPS, rede a cada ≤ 20 s</a:t>
                       </a:r>
                     </a:p>
                   </a:txBody>
@@ -3914,7 +3914,7 @@
                           </a:solidFill>
                           <a:latin typeface="Plus Jakarta Sans"/>
                         </a:rPr>
-                        <a:t>8,3 %/h</a:t>
+                        <a:t>5,0 %/h</a:t>
                       </a:r>
                     </a:p>
                   </a:txBody>
@@ -3960,7 +3960,7 @@
                           </a:solidFill>
                           <a:latin typeface="Plus Jakarta Sans"/>
                         </a:rPr>
-                        <a:t>aparelho parado, mesma sessão</a:t>
+                        <a:t>parado; 99% dos fixos retidos</a:t>
                       </a:r>
                     </a:p>
                   </a:txBody>
@@ -3982,7 +3982,7 @@
                           </a:solidFill>
                           <a:latin typeface="Plus Jakarta Sans"/>
                         </a:rPr>
-                        <a:t>3,32</a:t>
+                        <a:t>0,56 (não mede o ruído)</a:t>
                       </a:r>
                     </a:p>
                   </a:txBody>
@@ -4167,7 +4167,7 @@
                 </a:solidFill>
                 <a:latin typeface="Plus Jakarta Sans"/>
               </a:rPr>
-              <a:t>Aparelho: Samsung SM-S926B · local: campus da UFLA · coletas: 22/10/2026 · comando: scripts\av1_evidencias.ps1 · semente 20261020</a:t>
+              <a:t>Aparelho: Samsung SM-S926B · coletas: 22/10/2026, campus da UFLA (sessão bloqueada de 21h12 fora do campus, coordenadas deslocadas) · scripts\av1_evidencias.ps1 · semente 20261020</a:t>
             </a:r>
           </a:p>
         </p:txBody>
@@ -4433,7 +4433,7 @@
                 </a:solidFill>
                 <a:latin typeface="Plus Jakarta Sans"/>
               </a:rPr>
-              <a:t>Sessão gravada: GPS parou ~3 min após a tela apagar (faltava a localização em segundo plano; corrigido e conferido em teste curto).</a:t>
+              <a:t>Sem localização em segundo plano o GPS parava ~3 min após apagar a tela; com ela, 87% do tempo e uma pausa de 4,5 min sem causa conhecida.</a:t>
             </a:r>
           </a:p>
           <a:p>
@@ -4449,7 +4449,7 @@
                 </a:solidFill>
                 <a:latin typeface="Plus Jakarta Sans"/>
               </a:rPr>
-              <a:t>Parado, o receptor retém a posição: a razão de otimismo mistura viés inicial e posição congelada.</a:t>
+              <a:t>Parado, o receptor retém a posição: o ensaio estático não mede o ruído.</a:t>
             </a:r>
           </a:p>
           <a:p>
@@ -4540,7 +4540,7 @@
                 </a:solidFill>
                 <a:latin typeface="Plus Jakarta Sans"/>
               </a:rPr>
-              <a:t>Pedir a localização em segundo plano dentro do app e regravar os 30 min com GPS</a:t>
+              <a:t>Pedir a localização em segundo plano no app; consumidor IMU com taxa fixa (D-22)</a:t>
             </a:r>
           </a:p>
           <a:p>

</xml_diff>